<commit_message>
Fill white Afrihealth template with Aurora content
Copy pitch details into the official white Afrihealth structure
without restyling the deck. Force all text bold with dark ink for
legibility on every slide.

Co-authored-by: ProximaOpal <ProximaOpal@users.noreply.github.com>
</commit_message>
<xml_diff>
--- a/pitch/AuroraTravels_Pitch_Deck.pptx
+++ b/pitch/AuroraTravels_Pitch_Deck.pptx
@@ -8103,6 +8103,11 @@
               <a:buNone/>
             </a:pPr>
             <a:r>
+              <a:rPr b="1">
+                <a:solidFill>
+                  <a:srgbClr val="141414"/>
+                </a:solidFill>
+              </a:rPr>
               <a:t/>
             </a:r>
             <a:endParaRPr/>
@@ -8151,7 +8156,7 @@
             <a:r>
               <a:rPr b="1" i="0" lang="en" sz="3000" u="none" cap="none" strike="noStrike">
                 <a:solidFill>
-                  <a:srgbClr val="1F2323"/>
+                  <a:srgbClr val="141414"/>
                 </a:solidFill>
                 <a:latin typeface="Google Sans"/>
                 <a:ea typeface="Google Sans"/>
@@ -8214,7 +8219,7 @@
             <a:r>
               <a:rPr b="1" i="0" lang="en" sz="1100" u="none" cap="none" strike="noStrike">
                 <a:solidFill>
-                  <a:srgbClr val="E41813"/>
+                  <a:srgbClr val="141414"/>
                 </a:solidFill>
                 <a:latin typeface="Google Sans"/>
                 <a:ea typeface="Google Sans"/>
@@ -8277,14 +8282,14 @@
             <a:r>
               <a:rPr b="1" i="1" lang="en" sz="1000" u="none" cap="none" strike="noStrike">
                 <a:solidFill>
-                  <a:srgbClr val="6B7573"/>
+                  <a:srgbClr val="141414"/>
                 </a:solidFill>
                 <a:latin typeface="Google Sans"/>
                 <a:ea typeface="Google Sans"/>
                 <a:cs typeface="Google Sans"/>
                 <a:sym typeface="Google Sans"/>
               </a:rPr>
-              <a:t>A Kenya-native app for parks, stays, verified crafts and student guides — connecting travelers to artisans and university guides with M-Pesa checkout.</a:t>
+              <a:t>KENYA · TRAVEL · CULTURE · COMMERCE</a:t>
             </a:r>
             <a:endParaRPr b="1" i="0" sz="1000" u="none" cap="none" strike="noStrike">
               <a:solidFill>
@@ -8298,7 +8303,32 @@
           </a:p>
           <a:p>
             <a:r>
-              <a:t>Built in Nairobi by ProximaOpal · auroratravels</a:t>
+              <a:rPr b="1">
+                <a:solidFill>
+                  <a:srgbClr val="141414"/>
+                </a:solidFill>
+              </a:rPr>
+              <a:t>A single, Kenya-native app for parks, stays, verified crafts and student guides — pitched for partnership and investment.</a:t>
+            </a:r>
+          </a:p>
+          <a:p>
+            <a:r>
+              <a:rPr b="1">
+                <a:solidFill>
+                  <a:srgbClr val="141414"/>
+                </a:solidFill>
+              </a:rPr>
+              <a:t>Discover 15 parks · Shop 28 verified crafts · Pay with native M-Pesa STK Push · Connect 12 university guides</a:t>
+            </a:r>
+          </a:p>
+          <a:p>
+            <a:r>
+              <a:rPr b="1">
+                <a:solidFill>
+                  <a:srgbClr val="141414"/>
+                </a:solidFill>
+              </a:rPr>
+              <a:t>Built in Nairobi by ProximaOpal — web &amp; AI product engineer · auroratravels</a:t>
             </a:r>
           </a:p>
         </p:txBody>
@@ -8478,7 +8508,7 @@
             <a:r>
               <a:rPr b="1" lang="en" sz="1700">
                 <a:solidFill>
-                  <a:srgbClr val="028F35"/>
+                  <a:srgbClr val="141414"/>
                 </a:solidFill>
                 <a:latin typeface="Google Sans"/>
                 <a:ea typeface="Google Sans"/>
@@ -8539,9 +8569,9 @@
               <a:buNone/>
             </a:pPr>
             <a:r>
-              <a:rPr b="1" lang="en" sz="800">
-                <a:solidFill>
-                  <a:srgbClr val="6B7573"/>
+              <a:rPr b="1" lang="en" sz="1000">
+                <a:solidFill>
+                  <a:srgbClr val="141414"/>
                 </a:solidFill>
                 <a:latin typeface="Google Sans"/>
                 <a:ea typeface="Google Sans"/>
@@ -8604,7 +8634,7 @@
             <a:r>
               <a:rPr b="1" lang="en" sz="2400">
                 <a:solidFill>
-                  <a:srgbClr val="1F2323"/>
+                  <a:srgbClr val="141414"/>
                 </a:solidFill>
                 <a:latin typeface="Google Sans"/>
                 <a:ea typeface="Google Sans"/>
@@ -8667,14 +8697,14 @@
             <a:r>
               <a:rPr b="1" lang="en" sz="1100">
                 <a:solidFill>
-                  <a:srgbClr val="028F35"/>
+                  <a:srgbClr val="141414"/>
                 </a:solidFill>
                 <a:latin typeface="Google Sans"/>
                 <a:ea typeface="Google Sans"/>
                 <a:cs typeface="Google Sans"/>
                 <a:sym typeface="Google Sans"/>
               </a:rPr>
-              <a:t>Why you're the right team to solve this</a:t>
+              <a:t>Why this team can build it</a:t>
             </a:r>
             <a:endParaRPr sz="1100">
               <a:solidFill>
@@ -8731,6 +8761,11 @@
               <a:buNone/>
             </a:pPr>
             <a:r>
+              <a:rPr b="1">
+                <a:solidFill>
+                  <a:srgbClr val="141414"/>
+                </a:solidFill>
+              </a:rPr>
               <a:t/>
             </a:r>
             <a:endParaRPr/>
@@ -8777,9 +8812,9 @@
               <a:buNone/>
             </a:pPr>
             <a:r>
-              <a:rPr i="1" lang="en" sz="700">
-                <a:solidFill>
-                  <a:srgbClr val="6B7573"/>
+              <a:rPr i="1" lang="en" sz="1000" b="1">
+                <a:solidFill>
+                  <a:srgbClr val="141414"/>
                 </a:solidFill>
                 <a:latin typeface="Arial"/>
                 <a:ea typeface="Arial"/>
@@ -8842,7 +8877,7 @@
             <a:r>
               <a:rPr b="1" lang="en" sz="1000">
                 <a:solidFill>
-                  <a:srgbClr val="1F2323"/>
+                  <a:srgbClr val="141414"/>
                 </a:solidFill>
                 <a:latin typeface="Nunito"/>
                 <a:ea typeface="Nunito"/>
@@ -8903,9 +8938,9 @@
               <a:buNone/>
             </a:pPr>
             <a:r>
-              <a:rPr b="1" lang="en" sz="800">
-                <a:solidFill>
-                  <a:srgbClr val="028F35"/>
+              <a:rPr b="1" lang="en" sz="1000">
+                <a:solidFill>
+                  <a:srgbClr val="141414"/>
                 </a:solidFill>
                 <a:latin typeface="Nunito"/>
                 <a:ea typeface="Nunito"/>
@@ -8966,16 +9001,16 @@
               <a:buNone/>
             </a:pPr>
             <a:r>
-              <a:rPr i="1" lang="en" sz="700">
-                <a:solidFill>
-                  <a:srgbClr val="6B7573"/>
+              <a:rPr i="1" lang="en" sz="1000" b="1">
+                <a:solidFill>
+                  <a:srgbClr val="141414"/>
                 </a:solidFill>
                 <a:latin typeface="Nunito"/>
                 <a:ea typeface="Nunito"/>
                 <a:cs typeface="Nunito"/>
                 <a:sym typeface="Nunito"/>
               </a:rPr>
-              <a:t>Nairobi-based web/AI builder; shipped Aurora Travels solo including maps, marketplace and live M-Pesa STK Push.</a:t>
+              <a:t>Web developer and UI/UX designer based in Nairobi. Designed, built and shipped Aurora Travels solo: frontend, interactive maps, craft marketplace and live M-Pesa STK Push.</a:t>
             </a:r>
             <a:endParaRPr sz="700">
               <a:solidFill>
@@ -9032,6 +9067,11 @@
               <a:buNone/>
             </a:pPr>
             <a:r>
+              <a:rPr b="1">
+                <a:solidFill>
+                  <a:srgbClr val="141414"/>
+                </a:solidFill>
+              </a:rPr>
               <a:t/>
             </a:r>
             <a:endParaRPr/>
@@ -9078,9 +9118,9 @@
               <a:buNone/>
             </a:pPr>
             <a:r>
-              <a:rPr i="1" lang="en" sz="700">
-                <a:solidFill>
-                  <a:srgbClr val="6B7573"/>
+              <a:rPr i="1" lang="en" sz="1000" b="1">
+                <a:solidFill>
+                  <a:srgbClr val="141414"/>
                 </a:solidFill>
                 <a:latin typeface="Arial"/>
                 <a:ea typeface="Arial"/>
@@ -9143,7 +9183,7 @@
             <a:r>
               <a:rPr b="1" lang="en" sz="1000">
                 <a:solidFill>
-                  <a:srgbClr val="1F2323"/>
+                  <a:srgbClr val="141414"/>
                 </a:solidFill>
                 <a:latin typeface="Nunito"/>
                 <a:ea typeface="Nunito"/>
@@ -9204,16 +9244,16 @@
               <a:buNone/>
             </a:pPr>
             <a:r>
-              <a:rPr b="1" lang="en" sz="800">
-                <a:solidFill>
-                  <a:srgbClr val="028F35"/>
+              <a:rPr b="1" lang="en" sz="1000">
+                <a:solidFill>
+                  <a:srgbClr val="141414"/>
                 </a:solidFill>
                 <a:latin typeface="Nunito"/>
                 <a:ea typeface="Nunito"/>
                 <a:cs typeface="Nunito"/>
                 <a:sym typeface="Nunito"/>
               </a:rPr>
-              <a:t>Tourism partnerships lead</a:t>
+              <a:t>Tourism &amp; hospitality partnerships lead</a:t>
             </a:r>
             <a:endParaRPr sz="800">
               <a:solidFill>
@@ -9267,9 +9307,9 @@
               <a:buNone/>
             </a:pPr>
             <a:r>
-              <a:rPr i="1" lang="en" sz="700">
-                <a:solidFill>
-                  <a:srgbClr val="6B7573"/>
+              <a:rPr i="1" lang="en" sz="1000" b="1">
+                <a:solidFill>
+                  <a:srgbClr val="141414"/>
                 </a:solidFill>
                 <a:latin typeface="Nunito"/>
                 <a:ea typeface="Nunito"/>
@@ -9333,6 +9373,11 @@
               <a:buNone/>
             </a:pPr>
             <a:r>
+              <a:rPr b="1">
+                <a:solidFill>
+                  <a:srgbClr val="141414"/>
+                </a:solidFill>
+              </a:rPr>
               <a:t/>
             </a:r>
             <a:endParaRPr/>
@@ -9379,9 +9424,9 @@
               <a:buNone/>
             </a:pPr>
             <a:r>
-              <a:rPr i="1" lang="en" sz="700">
-                <a:solidFill>
-                  <a:srgbClr val="6B7573"/>
+              <a:rPr i="1" lang="en" sz="1000" b="1">
+                <a:solidFill>
+                  <a:srgbClr val="141414"/>
                 </a:solidFill>
                 <a:latin typeface="Arial"/>
                 <a:ea typeface="Arial"/>
@@ -9444,7 +9489,7 @@
             <a:r>
               <a:rPr b="1" lang="en" sz="1000">
                 <a:solidFill>
-                  <a:srgbClr val="1F2323"/>
+                  <a:srgbClr val="141414"/>
                 </a:solidFill>
                 <a:latin typeface="Nunito"/>
                 <a:ea typeface="Nunito"/>
@@ -9505,9 +9550,9 @@
               <a:buNone/>
             </a:pPr>
             <a:r>
-              <a:rPr b="1" lang="en" sz="800">
-                <a:solidFill>
-                  <a:srgbClr val="028F35"/>
+              <a:rPr b="1" lang="en" sz="1000">
+                <a:solidFill>
+                  <a:srgbClr val="141414"/>
                 </a:solidFill>
                 <a:latin typeface="Nunito"/>
                 <a:ea typeface="Nunito"/>
@@ -9568,9 +9613,9 @@
               <a:buNone/>
             </a:pPr>
             <a:r>
-              <a:rPr i="1" lang="en" sz="700">
-                <a:solidFill>
-                  <a:srgbClr val="6B7573"/>
+              <a:rPr i="1" lang="en" sz="1000" b="1">
+                <a:solidFill>
+                  <a:srgbClr val="141414"/>
                 </a:solidFill>
                 <a:latin typeface="Nunito"/>
                 <a:ea typeface="Nunito"/>
@@ -9634,6 +9679,11 @@
               <a:buNone/>
             </a:pPr>
             <a:r>
+              <a:rPr b="1">
+                <a:solidFill>
+                  <a:srgbClr val="141414"/>
+                </a:solidFill>
+              </a:rPr>
               <a:t/>
             </a:r>
             <a:endParaRPr/>
@@ -9680,9 +9730,9 @@
               <a:buNone/>
             </a:pPr>
             <a:r>
-              <a:rPr i="1" lang="en" sz="700">
-                <a:solidFill>
-                  <a:srgbClr val="6B7573"/>
+              <a:rPr i="1" lang="en" sz="1000" b="1">
+                <a:solidFill>
+                  <a:srgbClr val="141414"/>
                 </a:solidFill>
                 <a:latin typeface="Arial"/>
                 <a:ea typeface="Arial"/>
@@ -9745,7 +9795,7 @@
             <a:r>
               <a:rPr b="1" lang="en" sz="1000">
                 <a:solidFill>
-                  <a:srgbClr val="1F2323"/>
+                  <a:srgbClr val="141414"/>
                 </a:solidFill>
                 <a:latin typeface="Nunito"/>
                 <a:ea typeface="Nunito"/>
@@ -9806,9 +9856,9 @@
               <a:buNone/>
             </a:pPr>
             <a:r>
-              <a:rPr b="1" lang="en" sz="800">
-                <a:solidFill>
-                  <a:srgbClr val="028F35"/>
+              <a:rPr b="1" lang="en" sz="1000">
+                <a:solidFill>
+                  <a:srgbClr val="141414"/>
                 </a:solidFill>
                 <a:latin typeface="Nunito"/>
                 <a:ea typeface="Nunito"/>
@@ -9869,9 +9919,9 @@
               <a:buNone/>
             </a:pPr>
             <a:r>
-              <a:rPr i="1" lang="en" sz="700">
-                <a:solidFill>
-                  <a:srgbClr val="6B7573"/>
+              <a:rPr i="1" lang="en" sz="1000" b="1">
+                <a:solidFill>
+                  <a:srgbClr val="141414"/>
                 </a:solidFill>
                 <a:latin typeface="Nunito"/>
                 <a:ea typeface="Nunito"/>
@@ -10040,7 +10090,7 @@
             <a:r>
               <a:rPr b="1" lang="en" sz="1700">
                 <a:solidFill>
-                  <a:srgbClr val="028F35"/>
+                  <a:srgbClr val="141414"/>
                 </a:solidFill>
                 <a:latin typeface="Google Sans"/>
                 <a:ea typeface="Google Sans"/>
@@ -10101,9 +10151,9 @@
               <a:buNone/>
             </a:pPr>
             <a:r>
-              <a:rPr b="1" lang="en" sz="800">
-                <a:solidFill>
-                  <a:srgbClr val="6B7573"/>
+              <a:rPr b="1" lang="en" sz="1000">
+                <a:solidFill>
+                  <a:srgbClr val="141414"/>
                 </a:solidFill>
                 <a:latin typeface="Google Sans"/>
                 <a:ea typeface="Google Sans"/>
@@ -10166,7 +10216,7 @@
             <a:r>
               <a:rPr b="1" lang="en" sz="2400">
                 <a:solidFill>
-                  <a:srgbClr val="1F2323"/>
+                  <a:srgbClr val="141414"/>
                 </a:solidFill>
                 <a:latin typeface="Google Sans"/>
                 <a:ea typeface="Google Sans"/>
@@ -10229,14 +10279,14 @@
             <a:r>
               <a:rPr b="1" lang="en" sz="1100">
                 <a:solidFill>
-                  <a:srgbClr val="028F35"/>
+                  <a:srgbClr val="141414"/>
                 </a:solidFill>
                 <a:latin typeface="Google Sans"/>
                 <a:ea typeface="Google Sans"/>
                 <a:cs typeface="Google Sans"/>
                 <a:sym typeface="Google Sans"/>
               </a:rPr>
-              <a:t>What you need, and what it enables</a:t>
+              <a:t>What Aurora Travels needs, and what it enables</a:t>
             </a:r>
             <a:endParaRPr sz="1100">
               <a:solidFill>
@@ -10295,6 +10345,11 @@
               <a:buNone/>
             </a:pPr>
             <a:r>
+              <a:rPr b="1">
+                <a:solidFill>
+                  <a:srgbClr val="141414"/>
+                </a:solidFill>
+              </a:rPr>
               <a:t/>
             </a:r>
             <a:endParaRPr>
@@ -10349,16 +10404,16 @@
               <a:buNone/>
             </a:pPr>
             <a:r>
-              <a:rPr i="1" lang="en" sz="1000">
-                <a:solidFill>
-                  <a:srgbClr val="6B7573"/>
+              <a:rPr i="1" lang="en" sz="1000" b="1">
+                <a:solidFill>
+                  <a:srgbClr val="141414"/>
                 </a:solidFill>
                 <a:latin typeface="Nunito"/>
                 <a:ea typeface="Nunito"/>
                 <a:cs typeface="Nunito"/>
                 <a:sym typeface="Nunito"/>
               </a:rPr>
-              <a:t>Funding / support requested</a:t>
+              <a:t>SEED / PARTNERSHIP CAPITAL</a:t>
             </a:r>
             <a:endParaRPr sz="1000">
               <a:solidFill>
@@ -10389,7 +10444,12 @@
               <a:buNone/>
             </a:pPr>
             <a:r>
-              <a:t>US$180,000 (~KES 23.4M at ~130 KES/USD) — 18-month Nairobi + Maasai Mara pilot.</a:t>
+              <a:rPr b="1">
+                <a:solidFill>
+                  <a:srgbClr val="141414"/>
+                </a:solidFill>
+              </a:rPr>
+              <a:t>US$180,000 ≈ KES 23.4 million (at ~130 KES/USD) — 18-month Nairobi + Maasai Mara pilot.</a:t>
             </a:r>
             <a:endParaRPr sz="1000">
               <a:solidFill>
@@ -10420,9 +10480,9 @@
               <a:buNone/>
             </a:pPr>
             <a:r>
-              <a:rPr i="1" lang="en" sz="1000">
-                <a:solidFill>
-                  <a:srgbClr val="6B7573"/>
+              <a:rPr i="1" lang="en" sz="1000" b="1">
+                <a:solidFill>
+                  <a:srgbClr val="141414"/>
                 </a:solidFill>
                 <a:latin typeface="Nunito"/>
                 <a:ea typeface="Nunito"/>
@@ -10460,16 +10520,16 @@
               <a:buNone/>
             </a:pPr>
             <a:r>
-              <a:rPr i="1" lang="en" sz="1000">
-                <a:solidFill>
-                  <a:srgbClr val="6B7573"/>
+              <a:rPr i="1" lang="en" sz="1000" b="1">
+                <a:solidFill>
+                  <a:srgbClr val="141414"/>
                 </a:solidFill>
                 <a:latin typeface="Nunito"/>
                 <a:ea typeface="Nunito"/>
                 <a:cs typeface="Nunito"/>
                 <a:sym typeface="Nunito"/>
               </a:rPr>
-              <a:t>Use of funds:</a:t>
+              <a:t>USE OF FUNDS:</a:t>
             </a:r>
             <a:endParaRPr sz="1000">
               <a:solidFill>
@@ -10500,6 +10560,11 @@
               <a:buNone/>
             </a:pPr>
             <a:r>
+              <a:rPr b="1">
+                <a:solidFill>
+                  <a:srgbClr val="141414"/>
+                </a:solidFill>
+              </a:rPr>
               <a:t>• Product &amp; engineering — 40% (US$72,000)</a:t>
             </a:r>
             <a:endParaRPr sz="1000">
@@ -10531,9 +10596,9 @@
               <a:buNone/>
             </a:pPr>
             <a:r>
-              <a:rPr i="1" lang="en" sz="1000">
-                <a:solidFill>
-                  <a:srgbClr val="6B7573"/>
+              <a:rPr i="1" lang="en" sz="1000" b="1">
+                <a:solidFill>
+                  <a:srgbClr val="141414"/>
                 </a:solidFill>
                 <a:latin typeface="Nunito"/>
                 <a:ea typeface="Nunito"/>
@@ -10571,9 +10636,9 @@
               <a:buNone/>
             </a:pPr>
             <a:r>
-              <a:rPr i="1" lang="en" sz="1000">
-                <a:solidFill>
-                  <a:srgbClr val="6B7573"/>
+              <a:rPr i="1" lang="en" sz="1000" b="1">
+                <a:solidFill>
+                  <a:srgbClr val="141414"/>
                 </a:solidFill>
                 <a:latin typeface="Nunito"/>
                 <a:ea typeface="Nunito"/>
@@ -10611,9 +10676,9 @@
               <a:buNone/>
             </a:pPr>
             <a:r>
-              <a:rPr i="1" lang="en" sz="1000">
-                <a:solidFill>
-                  <a:srgbClr val="6B7573"/>
+              <a:rPr i="1" lang="en" sz="1000" b="1">
+                <a:solidFill>
+                  <a:srgbClr val="141414"/>
                 </a:solidFill>
                 <a:latin typeface="Nunito"/>
                 <a:ea typeface="Nunito"/>
@@ -10651,9 +10716,9 @@
               <a:buNone/>
             </a:pPr>
             <a:r>
-              <a:rPr i="1" lang="en" sz="1000">
-                <a:solidFill>
-                  <a:srgbClr val="6B7573"/>
+              <a:rPr i="1" lang="en" sz="1000" b="1">
+                <a:solidFill>
+                  <a:srgbClr val="141414"/>
                 </a:solidFill>
                 <a:latin typeface="Nunito"/>
                 <a:ea typeface="Nunito"/>
@@ -10719,6 +10784,11 @@
               <a:buNone/>
             </a:pPr>
             <a:r>
+              <a:rPr b="1">
+                <a:solidFill>
+                  <a:srgbClr val="141414"/>
+                </a:solidFill>
+              </a:rPr>
               <a:t/>
             </a:r>
             <a:endParaRPr/>
@@ -10768,16 +10838,16 @@
               <a:buNone/>
             </a:pPr>
             <a:r>
-              <a:rPr i="1" lang="en" sz="1000">
-                <a:solidFill>
-                  <a:srgbClr val="6B7573"/>
+              <a:rPr i="1" lang="en" sz="1000" b="1">
+                <a:solidFill>
+                  <a:srgbClr val="141414"/>
                 </a:solidFill>
                 <a:latin typeface="Nunito"/>
                 <a:ea typeface="Nunito"/>
                 <a:cs typeface="Nunito"/>
                 <a:sym typeface="Nunito"/>
               </a:rPr>
-              <a:t>12–24 month projection</a:t>
+              <a:t>12–24 MONTH PROJECTION</a:t>
             </a:r>
             <a:endParaRPr sz="1000">
               <a:solidFill>
@@ -10808,6 +10878,11 @@
               <a:buNone/>
             </a:pPr>
             <a:r>
+              <a:rPr b="1">
+                <a:solidFill>
+                  <a:srgbClr val="141414"/>
+                </a:solidFill>
+              </a:rPr>
               <a:t>Shop partners onboarded (model): 24 → 40 → 65 → 90 → 120 → 160 → 210 → 270 over 8 quarters.</a:t>
             </a:r>
             <a:endParaRPr sz="1000">
@@ -10839,9 +10914,9 @@
               <a:buNone/>
             </a:pPr>
             <a:r>
-              <a:rPr i="1" lang="en" sz="1000">
-                <a:solidFill>
-                  <a:srgbClr val="6B7573"/>
+              <a:rPr i="1" lang="en" sz="1000" b="1">
+                <a:solidFill>
+                  <a:srgbClr val="141414"/>
                 </a:solidFill>
                 <a:latin typeface="Nunito"/>
                 <a:ea typeface="Nunito"/>
@@ -10879,9 +10954,9 @@
               <a:buNone/>
             </a:pPr>
             <a:r>
-              <a:rPr i="1" lang="en" sz="1000">
-                <a:solidFill>
-                  <a:srgbClr val="6B7573"/>
+              <a:rPr i="1" lang="en" sz="1000" b="1">
+                <a:solidFill>
+                  <a:srgbClr val="141414"/>
                 </a:solidFill>
                 <a:latin typeface="Nunito"/>
                 <a:ea typeface="Nunito"/>
@@ -10919,9 +10994,49 @@
               <a:buNone/>
             </a:pPr>
             <a:r>
-              <a:rPr i="1" lang="en" sz="1000">
-                <a:solidFill>
-                  <a:srgbClr val="6B7573"/>
+              <a:rPr i="1" lang="en" sz="1000" b="1">
+                <a:solidFill>
+                  <a:srgbClr val="141414"/>
+                </a:solidFill>
+                <a:latin typeface="Nunito"/>
+                <a:ea typeface="Nunito"/>
+                <a:cs typeface="Nunito"/>
+                <a:sym typeface="Nunito"/>
+              </a:rPr>
+              <a:t>Ask and growth curve are founder-proposed for the pilot — not achieved figures.</a:t>
+            </a:r>
+            <a:endParaRPr sz="1000">
+              <a:solidFill>
+                <a:schemeClr val="dk1"/>
+              </a:solidFill>
+              <a:latin typeface="Nunito"/>
+              <a:ea typeface="Nunito"/>
+              <a:cs typeface="Nunito"/>
+              <a:sym typeface="Nunito"/>
+            </a:endParaRPr>
+          </a:p>
+          <a:p>
+            <a:pPr indent="0" lvl="0" marL="0" marR="0" rtl="0" algn="l">
+              <a:lnSpc>
+                <a:spcPct val="125000"/>
+              </a:lnSpc>
+              <a:spcBef>
+                <a:spcPts val="0"/>
+              </a:spcBef>
+              <a:spcAft>
+                <a:spcPts val="0"/>
+              </a:spcAft>
+              <a:buClr>
+                <a:srgbClr val="6B7573"/>
+              </a:buClr>
+              <a:buSzPts val="1000"/>
+              <a:buFont typeface="Arial"/>
+              <a:buNone/>
+            </a:pPr>
+            <a:r>
+              <a:rPr i="1" lang="en" sz="1000" b="1">
+                <a:solidFill>
+                  <a:srgbClr val="141414"/>
                 </a:solidFill>
                 <a:latin typeface="Nunito"/>
                 <a:ea typeface="Nunito"/>
@@ -10959,49 +11074,9 @@
               <a:buNone/>
             </a:pPr>
             <a:r>
-              <a:rPr i="1" lang="en" sz="1000">
-                <a:solidFill>
-                  <a:srgbClr val="6B7573"/>
-                </a:solidFill>
-                <a:latin typeface="Nunito"/>
-                <a:ea typeface="Nunito"/>
-                <a:cs typeface="Nunito"/>
-                <a:sym typeface="Nunito"/>
-              </a:rPr>
-              <a:t/>
-            </a:r>
-            <a:endParaRPr sz="1000">
-              <a:solidFill>
-                <a:schemeClr val="dk1"/>
-              </a:solidFill>
-              <a:latin typeface="Nunito"/>
-              <a:ea typeface="Nunito"/>
-              <a:cs typeface="Nunito"/>
-              <a:sym typeface="Nunito"/>
-            </a:endParaRPr>
-          </a:p>
-          <a:p>
-            <a:pPr indent="0" lvl="0" marL="0" marR="0" rtl="0" algn="l">
-              <a:lnSpc>
-                <a:spcPct val="125000"/>
-              </a:lnSpc>
-              <a:spcBef>
-                <a:spcPts val="0"/>
-              </a:spcBef>
-              <a:spcAft>
-                <a:spcPts val="0"/>
-              </a:spcAft>
-              <a:buClr>
-                <a:srgbClr val="6B7573"/>
-              </a:buClr>
-              <a:buSzPts val="1000"/>
-              <a:buFont typeface="Arial"/>
-              <a:buNone/>
-            </a:pPr>
-            <a:r>
-              <a:rPr i="1" lang="en" sz="1000">
-                <a:solidFill>
-                  <a:srgbClr val="6B7573"/>
+              <a:rPr i="1" lang="en" sz="1000" b="1">
+                <a:solidFill>
+                  <a:srgbClr val="141414"/>
                 </a:solidFill>
                 <a:latin typeface="Nunito"/>
                 <a:ea typeface="Nunito"/>
@@ -11170,7 +11245,7 @@
             <a:r>
               <a:rPr b="1" lang="en" sz="1700">
                 <a:solidFill>
-                  <a:srgbClr val="028F35"/>
+                  <a:srgbClr val="141414"/>
                 </a:solidFill>
                 <a:latin typeface="Google Sans"/>
                 <a:ea typeface="Google Sans"/>
@@ -11231,9 +11306,9 @@
               <a:buNone/>
             </a:pPr>
             <a:r>
-              <a:rPr b="1" lang="en" sz="800">
-                <a:solidFill>
-                  <a:srgbClr val="6B7573"/>
+              <a:rPr b="1" lang="en" sz="1000">
+                <a:solidFill>
+                  <a:srgbClr val="141414"/>
                 </a:solidFill>
                 <a:latin typeface="Google Sans"/>
                 <a:ea typeface="Google Sans"/>
@@ -11296,7 +11371,7 @@
             <a:r>
               <a:rPr b="1" lang="en" sz="2400">
                 <a:solidFill>
-                  <a:srgbClr val="1F2323"/>
+                  <a:srgbClr val="141414"/>
                 </a:solidFill>
                 <a:latin typeface="Google Sans"/>
                 <a:ea typeface="Google Sans"/>
@@ -11359,14 +11434,14 @@
             <a:r>
               <a:rPr b="1" lang="en" sz="1100">
                 <a:solidFill>
-                  <a:srgbClr val="028F35"/>
+                  <a:srgbClr val="141414"/>
                 </a:solidFill>
                 <a:latin typeface="Nunito"/>
                 <a:ea typeface="Nunito"/>
                 <a:cs typeface="Nunito"/>
                 <a:sym typeface="Nunito"/>
               </a:rPr>
-              <a:t>Kenya’s travel experience is fragmented — and its creative economy is invisible online</a:t>
+              <a:t>Kenya's travel experience is fragmented — and its creative economy is invisible online</a:t>
             </a:r>
             <a:endParaRPr sz="1100">
               <a:solidFill>
@@ -11425,6 +11500,11 @@
               <a:buNone/>
             </a:pPr>
             <a:r>
+              <a:rPr b="1">
+                <a:solidFill>
+                  <a:srgbClr val="141414"/>
+                </a:solidFill>
+              </a:rPr>
               <a:t/>
             </a:r>
             <a:endParaRPr/>
@@ -11474,16 +11554,16 @@
               <a:buNone/>
             </a:pPr>
             <a:r>
-              <a:rPr i="1" lang="en" sz="1000">
-                <a:solidFill>
-                  <a:srgbClr val="6B7573"/>
+              <a:rPr i="1" lang="en" sz="1000" b="1">
+                <a:solidFill>
+                  <a:srgbClr val="141414"/>
                 </a:solidFill>
                 <a:latin typeface="Nunito"/>
                 <a:ea typeface="Nunito"/>
                 <a:cs typeface="Nunito"/>
                 <a:sym typeface="Nunito"/>
               </a:rPr>
-              <a:t>• International arrivals rose 9% YoY to 2.7M in 2025 (5.2M domestic; 7.9M total), yet travelers still stitch together separate tools for parks, stays, crafts and guides — mostly via commission-heavy foreign platforms.</a:t>
+              <a:t>• International arrivals rose 9% year-on-year to 2.7 million in 2025 (from 2.47M in 2024), with 5.2M domestic trips — 7.9M total visitors — yet travelers still stitch together separate tools for parks, stays, curio shopping and guides, mostly through commission-heavy foreign booking platforms.</a:t>
             </a:r>
             <a:endParaRPr sz="1000">
               <a:solidFill>
@@ -11514,7 +11594,12 @@
               <a:buNone/>
             </a:pPr>
             <a:r>
-              <a:t>• Kenya’s informal / Jua Kali and MSE economy contributes an estimated 24–33% of GDP, but most craft artisans lack a verified digital storefront into tourist demand.</a:t>
+              <a:rPr b="1">
+                <a:solidFill>
+                  <a:srgbClr val="141414"/>
+                </a:solidFill>
+              </a:rPr>
+              <a:t>• Kenya's informal / Jua Kali and MSE economy contributes an estimated 24–33% of GDP and the bulk of new jobs, but most craft artisans still lack a verified, direct digital storefront into tourist demand.</a:t>
             </a:r>
             <a:endParaRPr sz="1000">
               <a:solidFill>
@@ -11545,16 +11630,16 @@
               <a:buNone/>
             </a:pPr>
             <a:r>
-              <a:rPr i="1" lang="en" sz="1000">
-                <a:solidFill>
-                  <a:srgbClr val="6B7573"/>
+              <a:rPr i="1" lang="en" sz="1000" b="1">
+                <a:solidFill>
+                  <a:srgbClr val="141414"/>
                 </a:solidFill>
                 <a:latin typeface="Nunito"/>
                 <a:ea typeface="Nunito"/>
                 <a:cs typeface="Nunito"/>
                 <a:sym typeface="Nunito"/>
               </a:rPr>
-              <a:t>• Federation of Kenya Employers cites 67% unemployment among Kenyans aged 15–34 — deep local knowledge sits idle instead of being monetized as guiding.</a:t>
+              <a:t>• Federation of Kenya Employers cites a 67% unemployment rate among Kenyans aged 15–34 — deep local knowledge sits idle instead of being monetized as guiding services.</a:t>
             </a:r>
             <a:endParaRPr sz="1000">
               <a:solidFill>
@@ -11585,6 +11670,11 @@
               <a:buNone/>
             </a:pPr>
             <a:r>
+              <a:rPr b="1">
+                <a:solidFill>
+                  <a:srgbClr val="141414"/>
+                </a:solidFill>
+              </a:rPr>
               <a:t/>
             </a:r>
             <a:endParaRPr sz="1000">
@@ -11616,9 +11706,9 @@
               <a:buNone/>
             </a:pPr>
             <a:r>
-              <a:rPr i="1" lang="en" sz="1000">
-                <a:solidFill>
-                  <a:srgbClr val="6B7573"/>
+              <a:rPr i="1" lang="en" sz="1000" b="1">
+                <a:solidFill>
+                  <a:srgbClr val="141414"/>
                 </a:solidFill>
                 <a:latin typeface="Nunito"/>
                 <a:ea typeface="Nunito"/>
@@ -11656,6 +11746,11 @@
               <a:buNone/>
             </a:pPr>
             <a:r>
+              <a:rPr b="1">
+                <a:solidFill>
+                  <a:srgbClr val="141414"/>
+                </a:solidFill>
+              </a:rPr>
               <a:t/>
             </a:r>
             <a:endParaRPr sz="1000">
@@ -11687,9 +11782,9 @@
               <a:buNone/>
             </a:pPr>
             <a:r>
-              <a:rPr i="1" lang="en" sz="1000">
-                <a:solidFill>
-                  <a:srgbClr val="6B7573"/>
+              <a:rPr i="1" lang="en" sz="1000" b="1">
+                <a:solidFill>
+                  <a:srgbClr val="141414"/>
                 </a:solidFill>
                 <a:latin typeface="Nunito"/>
                 <a:ea typeface="Nunito"/>
@@ -11755,6 +11850,11 @@
               <a:buNone/>
             </a:pPr>
             <a:r>
+              <a:rPr b="1">
+                <a:solidFill>
+                  <a:srgbClr val="141414"/>
+                </a:solidFill>
+              </a:rPr>
               <a:t/>
             </a:r>
             <a:endParaRPr/>
@@ -11804,9 +11904,9 @@
               <a:buNone/>
             </a:pPr>
             <a:r>
-              <a:rPr i="1" lang="en" sz="1000">
-                <a:solidFill>
-                  <a:srgbClr val="6B7573"/>
+              <a:rPr i="1" lang="en" sz="1000" b="1">
+                <a:solidFill>
+                  <a:srgbClr val="141414"/>
                 </a:solidFill>
                 <a:latin typeface="Nunito"/>
                 <a:ea typeface="Nunito"/>
@@ -11844,7 +11944,12 @@
               <a:buNone/>
             </a:pPr>
             <a:r>
-              <a:t>67% — FKE figure for ages 15–34 without adequate employment</a:t>
+              <a:rPr b="1">
+                <a:solidFill>
+                  <a:srgbClr val="141414"/>
+                </a:solidFill>
+              </a:rPr>
+              <a:t>67% — FKE figure for Kenyans aged 15–34 without adequate employment</a:t>
             </a:r>
             <a:endParaRPr sz="1000">
               <a:solidFill>
@@ -11875,16 +11980,16 @@
               <a:buNone/>
             </a:pPr>
             <a:r>
-              <a:rPr i="1" lang="en" sz="1000">
-                <a:solidFill>
-                  <a:srgbClr val="6B7573"/>
+              <a:rPr i="1" lang="en" sz="1000" b="1">
+                <a:solidFill>
+                  <a:srgbClr val="141414"/>
                 </a:solidFill>
                 <a:latin typeface="Nunito"/>
                 <a:ea typeface="Nunito"/>
                 <a:cs typeface="Nunito"/>
                 <a:sym typeface="Nunito"/>
               </a:rPr>
-              <a:t>2.7M international arrivals in 2025 (+9% YoY)</a:t>
+              <a:t>2.7M international arrivals in 2025, up 9% YoY; KES 0.5T tourism earnings</a:t>
             </a:r>
             <a:endParaRPr sz="1000">
               <a:solidFill>
@@ -11915,16 +12020,16 @@
               <a:buNone/>
             </a:pPr>
             <a:r>
-              <a:rPr i="1" lang="en" sz="1000">
-                <a:solidFill>
-                  <a:srgbClr val="6B7573"/>
+              <a:rPr i="1" lang="en" sz="1000" b="1">
+                <a:solidFill>
+                  <a:srgbClr val="141414"/>
                 </a:solidFill>
                 <a:latin typeface="Nunito"/>
                 <a:ea typeface="Nunito"/>
                 <a:cs typeface="Nunito"/>
                 <a:sym typeface="Nunito"/>
               </a:rPr>
-              <a:t>KES ~0.5T (~US$3.8B) tourism earnings (Ministry / Magical Kenya 2025)</a:t>
+              <a:t>Sources: Kenya Ministry of Tourism &amp; Wildlife / Magical Kenya 2025; FKE; FinAccess / Daily Nation on informal GDP share (24–33%).</a:t>
             </a:r>
             <a:endParaRPr sz="1000">
               <a:solidFill>
@@ -11955,9 +12060,9 @@
               <a:buNone/>
             </a:pPr>
             <a:r>
-              <a:rPr i="1" lang="en" sz="1000">
-                <a:solidFill>
-                  <a:srgbClr val="6B7573"/>
+              <a:rPr i="1" lang="en" sz="1000" b="1">
+                <a:solidFill>
+                  <a:srgbClr val="141414"/>
                 </a:solidFill>
                 <a:latin typeface="Nunito"/>
                 <a:ea typeface="Nunito"/>
@@ -12126,7 +12231,7 @@
             <a:r>
               <a:rPr b="1" lang="en" sz="1700">
                 <a:solidFill>
-                  <a:srgbClr val="028F35"/>
+                  <a:srgbClr val="141414"/>
                 </a:solidFill>
                 <a:latin typeface="Google Sans"/>
                 <a:ea typeface="Google Sans"/>
@@ -12187,9 +12292,9 @@
               <a:buNone/>
             </a:pPr>
             <a:r>
-              <a:rPr b="1" lang="en" sz="800">
-                <a:solidFill>
-                  <a:srgbClr val="6B7573"/>
+              <a:rPr b="1" lang="en" sz="1000">
+                <a:solidFill>
+                  <a:srgbClr val="141414"/>
                 </a:solidFill>
                 <a:latin typeface="Google Sans"/>
                 <a:ea typeface="Google Sans"/>
@@ -12252,7 +12357,7 @@
             <a:r>
               <a:rPr b="1" lang="en" sz="2400">
                 <a:solidFill>
-                  <a:srgbClr val="1F2323"/>
+                  <a:srgbClr val="141414"/>
                 </a:solidFill>
                 <a:latin typeface="Google Sans"/>
                 <a:ea typeface="Google Sans"/>
@@ -12315,14 +12420,14 @@
             <a:r>
               <a:rPr b="1" lang="en" sz="1100">
                 <a:solidFill>
-                  <a:srgbClr val="028F35"/>
+                  <a:srgbClr val="141414"/>
                 </a:solidFill>
                 <a:latin typeface="Google Sans"/>
                 <a:ea typeface="Google Sans"/>
                 <a:cs typeface="Google Sans"/>
                 <a:sym typeface="Google Sans"/>
               </a:rPr>
-              <a:t>One app: parks, stays, verified Kenyan crafts and student guides — paid by M-Pesa</a:t>
+              <a:t>One app: parks, stays, verified crafts and student guides — native to Kenya</a:t>
             </a:r>
             <a:endParaRPr sz="1100">
               <a:solidFill>
@@ -12375,6 +12480,11 @@
               <a:buNone/>
             </a:pPr>
             <a:r>
+              <a:rPr b="1">
+                <a:solidFill>
+                  <a:srgbClr val="141414"/>
+                </a:solidFill>
+              </a:rPr>
               <a:t/>
             </a:r>
             <a:endParaRPr/>
@@ -12423,7 +12533,7 @@
             <a:r>
               <a:rPr b="1" lang="en" sz="1100">
                 <a:solidFill>
-                  <a:srgbClr val="FFFFFF"/>
+                  <a:srgbClr val="141414"/>
                 </a:solidFill>
                 <a:latin typeface="Nunito"/>
                 <a:ea typeface="Nunito"/>
@@ -12489,6 +12599,11 @@
               <a:buNone/>
             </a:pPr>
             <a:r>
+              <a:rPr b="1">
+                <a:solidFill>
+                  <a:srgbClr val="141414"/>
+                </a:solidFill>
+              </a:rPr>
               <a:t/>
             </a:r>
             <a:endParaRPr/>
@@ -12538,16 +12653,16 @@
               <a:buNone/>
             </a:pPr>
             <a:r>
-              <a:rPr i="1" lang="en" sz="900">
-                <a:solidFill>
-                  <a:srgbClr val="6B7573"/>
+              <a:rPr i="1" lang="en" sz="900" b="1">
+                <a:solidFill>
+                  <a:srgbClr val="141414"/>
                 </a:solidFill>
                 <a:latin typeface="Nunito"/>
                 <a:ea typeface="Nunito"/>
                 <a:cs typeface="Nunito"/>
                 <a:sym typeface="Nunito"/>
               </a:rPr>
-              <a:t>A single web experience from discovering Kenya’s parks to buying a named artisan craft and pairing with a vetted university guide — checked out with native M-Pesa STK Push.</a:t>
+              <a:t>A single web experience from discovering Kenya's parks to buying a named artisan craft and pairing with a vetted university guide — checked out with native M-Pesa STK Push.</a:t>
             </a:r>
             <a:endParaRPr sz="900">
               <a:solidFill>
@@ -12600,6 +12715,11 @@
               <a:buNone/>
             </a:pPr>
             <a:r>
+              <a:rPr b="1">
+                <a:solidFill>
+                  <a:srgbClr val="141414"/>
+                </a:solidFill>
+              </a:rPr>
               <a:t/>
             </a:r>
             <a:endParaRPr/>
@@ -12648,7 +12768,7 @@
             <a:r>
               <a:rPr b="1" lang="en" sz="1100">
                 <a:solidFill>
-                  <a:srgbClr val="FFFFFF"/>
+                  <a:srgbClr val="141414"/>
                 </a:solidFill>
                 <a:latin typeface="Nunito"/>
                 <a:ea typeface="Nunito"/>
@@ -12714,6 +12834,11 @@
               <a:buNone/>
             </a:pPr>
             <a:r>
+              <a:rPr b="1">
+                <a:solidFill>
+                  <a:srgbClr val="141414"/>
+                </a:solidFill>
+              </a:rPr>
               <a:t/>
             </a:r>
             <a:endParaRPr/>
@@ -12763,16 +12888,16 @@
               <a:buNone/>
             </a:pPr>
             <a:r>
-              <a:rPr i="1" lang="en" sz="900">
-                <a:solidFill>
-                  <a:srgbClr val="6B7573"/>
+              <a:rPr i="1" lang="en" sz="900" b="1">
+                <a:solidFill>
+                  <a:srgbClr val="141414"/>
                 </a:solidFill>
                 <a:latin typeface="Nunito"/>
                 <a:ea typeface="Nunito"/>
                 <a:cs typeface="Nunito"/>
                 <a:sym typeface="Nunito"/>
               </a:rPr>
-              <a:t>Interactive map (15 parks) → travel &amp; stay booking → marketplace of 28 crafts tied to real shops and Google Maps pins → on-demand pairing with guides from 12 Kenyan universities.</a:t>
+              <a:t>Interactive map across 15 parks → unified travel &amp; stay booking → curated marketplace of 28 crafts tied to real shops and Google Maps pins → on-demand pairing with vetted university student guides.</a:t>
             </a:r>
             <a:endParaRPr sz="900">
               <a:solidFill>
@@ -12825,6 +12950,11 @@
               <a:buNone/>
             </a:pPr>
             <a:r>
+              <a:rPr b="1">
+                <a:solidFill>
+                  <a:srgbClr val="141414"/>
+                </a:solidFill>
+              </a:rPr>
               <a:t/>
             </a:r>
             <a:endParaRPr/>
@@ -12873,7 +13003,7 @@
             <a:r>
               <a:rPr b="1" lang="en" sz="1100">
                 <a:solidFill>
-                  <a:srgbClr val="FFFFFF"/>
+                  <a:srgbClr val="141414"/>
                 </a:solidFill>
                 <a:latin typeface="Nunito"/>
                 <a:ea typeface="Nunito"/>
@@ -12939,6 +13069,11 @@
               <a:buNone/>
             </a:pPr>
             <a:r>
+              <a:rPr b="1">
+                <a:solidFill>
+                  <a:srgbClr val="141414"/>
+                </a:solidFill>
+              </a:rPr>
               <a:t/>
             </a:r>
             <a:endParaRPr>
@@ -12993,16 +13128,16 @@
               <a:buNone/>
             </a:pPr>
             <a:r>
-              <a:rPr i="1" lang="en" sz="900">
-                <a:solidFill>
-                  <a:srgbClr val="6B7573"/>
+              <a:rPr i="1" lang="en" sz="900" b="1">
+                <a:solidFill>
+                  <a:srgbClr val="141414"/>
                 </a:solidFill>
                 <a:latin typeface="Nunito"/>
                 <a:ea typeface="Nunito"/>
                 <a:cs typeface="Nunito"/>
                 <a:sym typeface="Nunito"/>
               </a:rPr>
-              <a:t>Built on Kenya’s own payment rail (~98% of mobile subscriptions use mobile money, CA Kenya) instead of card-only global OTAs; every shop and guide is named and mappable; guiding fees go to Kenyan students.</a:t>
+              <a:t>Built on Kenya's own payment rail (mobile money used by ~98% of mobile subscriptions, CA Kenya Dec 2025) instead of card-only global platforms; every shop and guide is named and mappable; guiding fees go to Kenyan students.</a:t>
             </a:r>
             <a:endParaRPr sz="900">
               <a:solidFill>
@@ -13164,7 +13299,7 @@
             <a:r>
               <a:rPr b="1" lang="en" sz="1700">
                 <a:solidFill>
-                  <a:srgbClr val="028F35"/>
+                  <a:srgbClr val="141414"/>
                 </a:solidFill>
                 <a:latin typeface="Google Sans"/>
                 <a:ea typeface="Google Sans"/>
@@ -13225,9 +13360,9 @@
               <a:buNone/>
             </a:pPr>
             <a:r>
-              <a:rPr b="1" lang="en" sz="800">
-                <a:solidFill>
-                  <a:srgbClr val="6B7573"/>
+              <a:rPr b="1" lang="en" sz="1000">
+                <a:solidFill>
+                  <a:srgbClr val="141414"/>
                 </a:solidFill>
                 <a:latin typeface="Google Sans"/>
                 <a:ea typeface="Google Sans"/>
@@ -13290,7 +13425,7 @@
             <a:r>
               <a:rPr b="1" lang="en" sz="2400">
                 <a:solidFill>
-                  <a:srgbClr val="1F2323"/>
+                  <a:srgbClr val="141414"/>
                 </a:solidFill>
                 <a:latin typeface="Google Sans"/>
                 <a:ea typeface="Google Sans"/>
@@ -13353,14 +13488,14 @@
             <a:r>
               <a:rPr b="1" lang="en" sz="1100">
                 <a:solidFill>
-                  <a:srgbClr val="028F35"/>
+                  <a:srgbClr val="141414"/>
                 </a:solidFill>
                 <a:latin typeface="Nunito"/>
                 <a:ea typeface="Nunito"/>
                 <a:cs typeface="Nunito"/>
                 <a:sym typeface="Nunito"/>
               </a:rPr>
-              <a:t>Four steps, one continuous journey — live build today</a:t>
+              <a:t>Four steps, one continuous journey</a:t>
             </a:r>
             <a:endParaRPr sz="1100">
               <a:solidFill>
@@ -13419,6 +13554,11 @@
               <a:buNone/>
             </a:pPr>
             <a:r>
+              <a:rPr b="1">
+                <a:solidFill>
+                  <a:srgbClr val="141414"/>
+                </a:solidFill>
+              </a:rPr>
               <a:t/>
             </a:r>
             <a:endParaRPr/>
@@ -13468,16 +13608,16 @@
               <a:buNone/>
             </a:pPr>
             <a:r>
-              <a:rPr i="1" lang="en" sz="1000">
-                <a:solidFill>
-                  <a:srgbClr val="6B7573"/>
+              <a:rPr i="1" lang="en" sz="1000" b="1">
+                <a:solidFill>
+                  <a:srgbClr val="141414"/>
                 </a:solidFill>
                 <a:latin typeface="Nunito"/>
                 <a:ea typeface="Nunito"/>
                 <a:cs typeface="Nunito"/>
                 <a:sym typeface="Nunito"/>
               </a:rPr>
-              <a:t>Interactive map, integrated booking, working M-Pesa checkout, and a guide roster — with Kenyan craft and place photography throughout Artifacts and Guides.</a:t>
+              <a:t>The live build today: an interactive map, integrated booking, a working M-Pesa checkout, and a guide roster — with Kenyan craft &amp; place photography throughout.</a:t>
             </a:r>
             <a:endParaRPr sz="1000">
               <a:solidFill>
@@ -13536,6 +13676,11 @@
               <a:buNone/>
             </a:pPr>
             <a:r>
+              <a:rPr b="1">
+                <a:solidFill>
+                  <a:srgbClr val="141414"/>
+                </a:solidFill>
+              </a:rPr>
               <a:t/>
             </a:r>
             <a:endParaRPr/>
@@ -13584,7 +13729,7 @@
             <a:r>
               <a:rPr b="1" lang="en" sz="1000">
                 <a:solidFill>
-                  <a:srgbClr val="1F2323"/>
+                  <a:srgbClr val="141414"/>
                 </a:solidFill>
                 <a:latin typeface="Nunito"/>
                 <a:ea typeface="Nunito"/>
@@ -13645,16 +13790,16 @@
               <a:buNone/>
             </a:pPr>
             <a:r>
-              <a:rPr i="1" lang="en" sz="800">
-                <a:solidFill>
-                  <a:srgbClr val="6B7573"/>
+              <a:rPr i="1" lang="en" sz="1000" b="1">
+                <a:solidFill>
+                  <a:srgbClr val="141414"/>
                 </a:solidFill>
                 <a:latin typeface="Nunito"/>
                 <a:ea typeface="Nunito"/>
                 <a:cs typeface="Nunito"/>
                 <a:sym typeface="Nunito"/>
               </a:rPr>
-              <a:t>Browse 15 parks &amp; destinations on a live interactive map</a:t>
+              <a:t>Browse 15 national parks &amp; destinations across Kenya and Africa on a live interactive map, with search and weather.</a:t>
             </a:r>
             <a:endParaRPr sz="800">
               <a:solidFill>
@@ -13710,7 +13855,7 @@
             <a:r>
               <a:rPr b="1" lang="en" sz="1500">
                 <a:solidFill>
-                  <a:srgbClr val="6B7573"/>
+                  <a:srgbClr val="141414"/>
                 </a:solidFill>
                 <a:latin typeface="Calibri"/>
                 <a:ea typeface="Calibri"/>
@@ -13776,6 +13921,11 @@
               <a:buNone/>
             </a:pPr>
             <a:r>
+              <a:rPr b="1">
+                <a:solidFill>
+                  <a:srgbClr val="141414"/>
+                </a:solidFill>
+              </a:rPr>
               <a:t/>
             </a:r>
             <a:endParaRPr/>
@@ -13824,7 +13974,7 @@
             <a:r>
               <a:rPr b="1" lang="en" sz="1000">
                 <a:solidFill>
-                  <a:srgbClr val="1F2323"/>
+                  <a:srgbClr val="141414"/>
                 </a:solidFill>
                 <a:latin typeface="Nunito"/>
                 <a:ea typeface="Nunito"/>
@@ -13885,16 +14035,16 @@
               <a:buNone/>
             </a:pPr>
             <a:r>
-              <a:rPr i="1" lang="en" sz="800">
-                <a:solidFill>
-                  <a:srgbClr val="6B7573"/>
+              <a:rPr i="1" lang="en" sz="1000" b="1">
+                <a:solidFill>
+                  <a:srgbClr val="141414"/>
                 </a:solidFill>
                 <a:latin typeface="Nunito"/>
                 <a:ea typeface="Nunito"/>
                 <a:cs typeface="Nunito"/>
                 <a:sym typeface="Nunito"/>
               </a:rPr>
-              <a:t>Book travel and accommodation in the same flow</a:t>
+              <a:t>Book travel and accommodation in the same flow — no separate app or tab.</a:t>
             </a:r>
             <a:endParaRPr sz="800">
               <a:solidFill>
@@ -13950,7 +14100,7 @@
             <a:r>
               <a:rPr b="1" lang="en" sz="1500">
                 <a:solidFill>
-                  <a:srgbClr val="6B7573"/>
+                  <a:srgbClr val="141414"/>
                 </a:solidFill>
                 <a:latin typeface="Calibri"/>
                 <a:ea typeface="Calibri"/>
@@ -14016,6 +14166,11 @@
               <a:buNone/>
             </a:pPr>
             <a:r>
+              <a:rPr b="1">
+                <a:solidFill>
+                  <a:srgbClr val="141414"/>
+                </a:solidFill>
+              </a:rPr>
               <a:t/>
             </a:r>
             <a:endParaRPr/>
@@ -14064,7 +14219,7 @@
             <a:r>
               <a:rPr b="1" lang="en" sz="1000">
                 <a:solidFill>
-                  <a:srgbClr val="1F2323"/>
+                  <a:srgbClr val="141414"/>
                 </a:solidFill>
                 <a:latin typeface="Nunito"/>
                 <a:ea typeface="Nunito"/>
@@ -14125,16 +14280,16 @@
               <a:buNone/>
             </a:pPr>
             <a:r>
-              <a:rPr i="1" lang="en" sz="800">
-                <a:solidFill>
-                  <a:srgbClr val="6B7573"/>
+              <a:rPr i="1" lang="en" sz="1000" b="1">
+                <a:solidFill>
+                  <a:srgbClr val="141414"/>
                 </a:solidFill>
                 <a:latin typeface="Nunito"/>
                 <a:ea typeface="Nunito"/>
                 <a:cs typeface="Nunito"/>
                 <a:sym typeface="Nunito"/>
               </a:rPr>
-              <a:t>Buy authentic crafts from named Kenyan shops (Tabaka, Kazuri, Maasai Market)</a:t>
+              <a:t>Buy an authentic craft from a named shop, e.g. Tabaka Soapstone Cooperative in Kisii, mapped on Google Maps.</a:t>
             </a:r>
             <a:endParaRPr sz="800">
               <a:solidFill>
@@ -14190,7 +14345,7 @@
             <a:r>
               <a:rPr b="1" lang="en" sz="1500">
                 <a:solidFill>
-                  <a:srgbClr val="6B7573"/>
+                  <a:srgbClr val="141414"/>
                 </a:solidFill>
                 <a:latin typeface="Calibri"/>
                 <a:ea typeface="Calibri"/>
@@ -14256,6 +14411,11 @@
               <a:buNone/>
             </a:pPr>
             <a:r>
+              <a:rPr b="1">
+                <a:solidFill>
+                  <a:srgbClr val="141414"/>
+                </a:solidFill>
+              </a:rPr>
               <a:t/>
             </a:r>
             <a:endParaRPr/>
@@ -14304,7 +14464,7 @@
             <a:r>
               <a:rPr b="1" lang="en" sz="1000">
                 <a:solidFill>
-                  <a:srgbClr val="1F2323"/>
+                  <a:srgbClr val="141414"/>
                 </a:solidFill>
                 <a:latin typeface="Nunito"/>
                 <a:ea typeface="Nunito"/>
@@ -14365,16 +14525,16 @@
               <a:buNone/>
             </a:pPr>
             <a:r>
-              <a:rPr i="1" lang="en" sz="800">
-                <a:solidFill>
-                  <a:srgbClr val="6B7573"/>
+              <a:rPr i="1" lang="en" sz="1000" b="1">
+                <a:solidFill>
+                  <a:srgbClr val="141414"/>
                 </a:solidFill>
                 <a:latin typeface="Nunito"/>
                 <a:ea typeface="Nunito"/>
                 <a:cs typeface="Nunito"/>
                 <a:sym typeface="Nunito"/>
               </a:rPr>
-              <a:t>Pay by M-Pesa STK Push, then pair with a vetted student guide</a:t>
+              <a:t>Pay instantly by M-Pesa STK Push, then pair with a vetted student guide from one of 12 Kenyan universities.</a:t>
             </a:r>
             <a:endParaRPr sz="800">
               <a:solidFill>
@@ -14509,7 +14669,7 @@
             <a:r>
               <a:rPr b="1" lang="en" sz="1700">
                 <a:solidFill>
-                  <a:srgbClr val="028F35"/>
+                  <a:srgbClr val="141414"/>
                 </a:solidFill>
                 <a:latin typeface="Google Sans"/>
                 <a:ea typeface="Google Sans"/>
@@ -14570,9 +14730,9 @@
               <a:buNone/>
             </a:pPr>
             <a:r>
-              <a:rPr b="1" lang="en" sz="800">
-                <a:solidFill>
-                  <a:srgbClr val="6B7573"/>
+              <a:rPr b="1" lang="en" sz="1000">
+                <a:solidFill>
+                  <a:srgbClr val="141414"/>
                 </a:solidFill>
                 <a:latin typeface="Google Sans"/>
                 <a:ea typeface="Google Sans"/>
@@ -14635,7 +14795,7 @@
             <a:r>
               <a:rPr b="1" lang="en" sz="2400">
                 <a:solidFill>
-                  <a:srgbClr val="1F2323"/>
+                  <a:srgbClr val="141414"/>
                 </a:solidFill>
                 <a:latin typeface="Google Sans"/>
                 <a:ea typeface="Google Sans"/>
@@ -14698,7 +14858,7 @@
             <a:r>
               <a:rPr b="1" lang="en" sz="1100">
                 <a:solidFill>
-                  <a:srgbClr val="028F35"/>
+                  <a:srgbClr val="141414"/>
                 </a:solidFill>
                 <a:latin typeface="Google Sans"/>
                 <a:ea typeface="Google Sans"/>
@@ -14759,16 +14919,16 @@
               <a:buNone/>
             </a:pPr>
             <a:r>
-              <a:rPr i="1" lang="en" sz="900">
-                <a:solidFill>
-                  <a:srgbClr val="6B7573"/>
+              <a:rPr i="1" lang="en" sz="900" b="1">
+                <a:solidFill>
+                  <a:srgbClr val="141414"/>
                 </a:solidFill>
                 <a:latin typeface="Nunito"/>
                 <a:ea typeface="Nunito"/>
                 <a:cs typeface="Nunito"/>
                 <a:sym typeface="Nunito"/>
               </a:rPr>
-              <a:t>TAM US$12.7B  ·  SAM ~US$3.8B  ·  SOM US$45M GMV (3-yr model)</a:t>
+              <a:t>TAM — US$12.7B   ·   SAM — ~US$3.8B (KES 0.5T)   ·   SOM (3-yr, modeled) — US$45M GMV</a:t>
             </a:r>
             <a:endParaRPr sz="900">
               <a:solidFill>
@@ -14854,6 +15014,11 @@
               <a:buNone/>
             </a:pPr>
             <a:r>
+              <a:rPr b="1">
+                <a:solidFill>
+                  <a:srgbClr val="141414"/>
+                </a:solidFill>
+              </a:rPr>
               <a:t/>
             </a:r>
             <a:endParaRPr/>
@@ -14903,16 +15068,16 @@
               <a:buNone/>
             </a:pPr>
             <a:r>
-              <a:rPr i="1" lang="en" sz="900">
-                <a:solidFill>
-                  <a:srgbClr val="6B7573"/>
+              <a:rPr i="1" lang="en" sz="900" b="1">
+                <a:solidFill>
+                  <a:srgbClr val="141414"/>
                 </a:solidFill>
                 <a:latin typeface="Nunito"/>
                 <a:ea typeface="Nunito"/>
                 <a:cs typeface="Nunito"/>
                 <a:sym typeface="Nunito"/>
               </a:rPr>
-              <a:t>• TAM — US$12.7B: WTTC Travel &amp; Tourism contribution to Kenya in 2025 (9.3% of GDP; 1.8M jobs).</a:t>
+              <a:t>• TAM — US$12.7B: WTTC reports Travel &amp; Tourism contributed US$12.7 billion to Kenya's economy in 2025 (9.3% of GDP) and supported 1.8 million jobs (8.3% of employment). Source: WTTC Economic Impact Research 2025/26.</a:t>
             </a:r>
             <a:endParaRPr sz="900">
               <a:solidFill>
@@ -14943,7 +15108,12 @@
               <a:buNone/>
             </a:pPr>
             <a:r>
-              <a:t>• SAM — ~US$3.8B (KES 0.5T): Ministry-reported direct tourism earnings from 7.9M visitors (2.7M international + 5.2M domestic).</a:t>
+              <a:rPr b="1">
+                <a:solidFill>
+                  <a:srgbClr val="141414"/>
+                </a:solidFill>
+              </a:rPr>
+              <a:t>• SAM — ~US$3.8B (KES 0.5T): Government-reported direct tourism earnings from 7.9M visitors in 2025 (2.7M international + 5.2M domestic). Digitally reachable craft, guiding and local-booking spend sits inside this earnings base. Source: Kenya Ministry of Tourism &amp; Wildlife / Magical Kenya 2025.</a:t>
             </a:r>
             <a:endParaRPr sz="900">
               <a:solidFill>
@@ -14974,16 +15144,16 @@
               <a:buNone/>
             </a:pPr>
             <a:r>
-              <a:rPr i="1" lang="en" sz="900">
-                <a:solidFill>
-                  <a:srgbClr val="6B7573"/>
+              <a:rPr i="1" lang="en" sz="900" b="1">
+                <a:solidFill>
+                  <a:srgbClr val="141414"/>
                 </a:solidFill>
                 <a:latin typeface="Nunito"/>
                 <a:ea typeface="Nunito"/>
                 <a:cs typeface="Nunito"/>
                 <a:sym typeface="Nunito"/>
               </a:rPr>
-              <a:t>• SOM (3-yr, modeled) — US$45M GMV: illustrative ~1.2% capture of international visitor spend on crafts / experiences / guiding (~US$5.0B international spend, WTTC).</a:t>
+              <a:t>• SOM (3-yr, modeled) — US$45M GMV: Illustrative ~1.2% of international visitor spend on crafts/experiences/guiding (~US$5.0B international spend per WTTC) flowing through Aurora by year 3 — a model to validate in the Nairobi + Maasai Mara pilot, not an achieved figure.</a:t>
             </a:r>
             <a:endParaRPr sz="900">
               <a:solidFill>
@@ -15014,7 +15184,12 @@
               <a:buNone/>
             </a:pPr>
             <a:r>
-              <a:t>• Sources: WTTC EIR 2025/26; Kenya Ministry of Tourism &amp; Wildlife / Magical Kenya 2025.</a:t>
+              <a:rPr b="1">
+                <a:solidFill>
+                  <a:srgbClr val="141414"/>
+                </a:solidFill>
+              </a:rPr>
+              <a:t/>
             </a:r>
             <a:endParaRPr sz="900">
               <a:solidFill>
@@ -15045,9 +15220,9 @@
               <a:buNone/>
             </a:pPr>
             <a:r>
-              <a:rPr i="1" lang="en" sz="900">
-                <a:solidFill>
-                  <a:srgbClr val="6B7573"/>
+              <a:rPr i="1" lang="en" sz="900" b="1">
+                <a:solidFill>
+                  <a:srgbClr val="141414"/>
                 </a:solidFill>
                 <a:latin typeface="Nunito"/>
                 <a:ea typeface="Nunito"/>
@@ -15085,6 +15260,11 @@
               <a:buNone/>
             </a:pPr>
             <a:r>
+              <a:rPr b="1">
+                <a:solidFill>
+                  <a:srgbClr val="141414"/>
+                </a:solidFill>
+              </a:rPr>
               <a:t/>
             </a:r>
             <a:endParaRPr sz="900">
@@ -15116,9 +15296,9 @@
               <a:buNone/>
             </a:pPr>
             <a:r>
-              <a:rPr i="1" lang="en" sz="900">
-                <a:solidFill>
-                  <a:srgbClr val="6B7573"/>
+              <a:rPr i="1" lang="en" sz="900" b="1">
+                <a:solidFill>
+                  <a:srgbClr val="141414"/>
                 </a:solidFill>
                 <a:latin typeface="Nunito"/>
                 <a:ea typeface="Nunito"/>
@@ -15287,7 +15467,7 @@
             <a:r>
               <a:rPr b="1" lang="en" sz="1700">
                 <a:solidFill>
-                  <a:srgbClr val="028F35"/>
+                  <a:srgbClr val="141414"/>
                 </a:solidFill>
                 <a:latin typeface="Google Sans"/>
                 <a:ea typeface="Google Sans"/>
@@ -15348,9 +15528,9 @@
               <a:buNone/>
             </a:pPr>
             <a:r>
-              <a:rPr b="1" lang="en" sz="800">
-                <a:solidFill>
-                  <a:srgbClr val="6B7573"/>
+              <a:rPr b="1" lang="en" sz="1000">
+                <a:solidFill>
+                  <a:srgbClr val="141414"/>
                 </a:solidFill>
                 <a:latin typeface="Google Sans"/>
                 <a:ea typeface="Google Sans"/>
@@ -15413,7 +15593,7 @@
             <a:r>
               <a:rPr b="1" lang="en" sz="2400">
                 <a:solidFill>
-                  <a:srgbClr val="1F2323"/>
+                  <a:srgbClr val="141414"/>
                 </a:solidFill>
                 <a:latin typeface="Google Sans"/>
                 <a:ea typeface="Google Sans"/>
@@ -15476,14 +15656,14 @@
             <a:r>
               <a:rPr b="1" lang="en" sz="1100">
                 <a:solidFill>
-                  <a:srgbClr val="028F35"/>
+                  <a:srgbClr val="141414"/>
                 </a:solidFill>
                 <a:latin typeface="Nunito"/>
                 <a:ea typeface="Nunito"/>
                 <a:cs typeface="Nunito"/>
                 <a:sym typeface="Nunito"/>
               </a:rPr>
-              <a:t>How do you make money?</a:t>
+              <a:t>How Aurora Travels makes money</a:t>
             </a:r>
             <a:endParaRPr sz="1100">
               <a:solidFill>
@@ -15536,6 +15716,11 @@
               <a:buNone/>
             </a:pPr>
             <a:r>
+              <a:rPr b="1">
+                <a:solidFill>
+                  <a:srgbClr val="141414"/>
+                </a:solidFill>
+              </a:rPr>
               <a:t/>
             </a:r>
             <a:endParaRPr/>
@@ -15584,7 +15769,7 @@
             <a:r>
               <a:rPr b="1" lang="en" sz="1100">
                 <a:solidFill>
-                  <a:srgbClr val="FFFFFF"/>
+                  <a:srgbClr val="141414"/>
                 </a:solidFill>
                 <a:latin typeface="Nunito"/>
                 <a:ea typeface="Nunito"/>
@@ -15650,6 +15835,11 @@
               <a:buNone/>
             </a:pPr>
             <a:r>
+              <a:rPr b="1">
+                <a:solidFill>
+                  <a:srgbClr val="141414"/>
+                </a:solidFill>
+              </a:rPr>
               <a:t/>
             </a:r>
             <a:endParaRPr/>
@@ -15699,16 +15889,16 @@
               <a:buNone/>
             </a:pPr>
             <a:r>
-              <a:rPr i="1" lang="en" sz="900">
-                <a:solidFill>
-                  <a:srgbClr val="6B7573"/>
+              <a:rPr i="1" lang="en" sz="900" b="1">
+                <a:solidFill>
+                  <a:srgbClr val="141414"/>
                 </a:solidFill>
                 <a:latin typeface="Nunito"/>
                 <a:ea typeface="Nunito"/>
                 <a:cs typeface="Nunito"/>
                 <a:sym typeface="Nunito"/>
               </a:rPr>
-              <a:t>Craft GMV take-rate (~12%); guide-booking service fee (KES 500–800); 8–10% referral on travel &amp; stay; featured placement for shops (KES 3,000–8,000/mo) and guides.</a:t>
+              <a:t>12% average take-rate on craft GMV (below typical OTA bands); KES 500–800 guide-booking service fee per pairing; 8–10% referral commission on travel &amp; stay bookings; featured-placement fees for shops (KES 3,000–8,000/mo) and guides.</a:t>
             </a:r>
             <a:endParaRPr sz="900">
               <a:solidFill>
@@ -15761,6 +15951,11 @@
               <a:buNone/>
             </a:pPr>
             <a:r>
+              <a:rPr b="1">
+                <a:solidFill>
+                  <a:srgbClr val="141414"/>
+                </a:solidFill>
+              </a:rPr>
               <a:t/>
             </a:r>
             <a:endParaRPr/>
@@ -15809,7 +16004,7 @@
             <a:r>
               <a:rPr b="1" lang="en" sz="1100">
                 <a:solidFill>
-                  <a:srgbClr val="FFFFFF"/>
+                  <a:srgbClr val="141414"/>
                 </a:solidFill>
                 <a:latin typeface="Nunito"/>
                 <a:ea typeface="Nunito"/>
@@ -15875,6 +16070,11 @@
               <a:buNone/>
             </a:pPr>
             <a:r>
+              <a:rPr b="1">
+                <a:solidFill>
+                  <a:srgbClr val="141414"/>
+                </a:solidFill>
+              </a:rPr>
               <a:t/>
             </a:r>
             <a:endParaRPr/>
@@ -15924,16 +16124,16 @@
               <a:buNone/>
             </a:pPr>
             <a:r>
-              <a:rPr i="1" lang="en" sz="900">
-                <a:solidFill>
-                  <a:srgbClr val="6B7573"/>
+              <a:rPr i="1" lang="en" sz="900" b="1">
+                <a:solidFill>
+                  <a:srgbClr val="141414"/>
                 </a:solidFill>
                 <a:latin typeface="Nunito"/>
                 <a:ea typeface="Nunito"/>
                 <a:cs typeface="Nunito"/>
                 <a:sym typeface="Nunito"/>
               </a:rPr>
-              <a:t>Live catalogue KES 2,200–15,200 (~US$17–$118) across 28 crafts. Modeled below typical OTA 20–30% commissions (Viator / GetYourGuide) because checkout is native M-Pesa.</a:t>
+              <a:t>Live catalogue prices run from KES 2,200 to KES 15,200 (~US$17–$118) across 28 crafts. Global tour OTAs commonly take 20–30% (Viator ~20–25% base; GetYourGuide 20–30%). Aurora undercuts that with M-Pesa-native checkout — no card gateway friction where ~98% of mobile subscriptions use mobile money.</a:t>
             </a:r>
             <a:endParaRPr sz="900">
               <a:solidFill>
@@ -15986,6 +16186,11 @@
               <a:buNone/>
             </a:pPr>
             <a:r>
+              <a:rPr b="1">
+                <a:solidFill>
+                  <a:srgbClr val="141414"/>
+                </a:solidFill>
+              </a:rPr>
               <a:t/>
             </a:r>
             <a:endParaRPr/>
@@ -16034,7 +16239,7 @@
             <a:r>
               <a:rPr b="1" lang="en" sz="1100">
                 <a:solidFill>
-                  <a:srgbClr val="FFFFFF"/>
+                  <a:srgbClr val="141414"/>
                 </a:solidFill>
                 <a:latin typeface="Nunito"/>
                 <a:ea typeface="Nunito"/>
@@ -16100,6 +16305,11 @@
               <a:buNone/>
             </a:pPr>
             <a:r>
+              <a:rPr b="1">
+                <a:solidFill>
+                  <a:srgbClr val="141414"/>
+                </a:solidFill>
+              </a:rPr>
               <a:t/>
             </a:r>
             <a:endParaRPr/>
@@ -16149,16 +16359,16 @@
               <a:buNone/>
             </a:pPr>
             <a:r>
-              <a:rPr i="1" lang="en" sz="900">
-                <a:solidFill>
-                  <a:srgbClr val="6B7573"/>
+              <a:rPr i="1" lang="en" sz="900" b="1">
+                <a:solidFill>
+                  <a:srgbClr val="141414"/>
                 </a:solidFill>
                 <a:latin typeface="Nunito"/>
                 <a:ea typeface="Nunito"/>
                 <a:cs typeface="Nunito"/>
                 <a:sym typeface="Nunito"/>
               </a:rPr>
-              <a:t>Low CAC via university guide network and mapped shop partners. At modeled Y3 GMV US$45M and ~11% blended take-rate → ~US$5.0M platform revenue. LTV compounds across trips, crafts and guides.</a:t>
+              <a:t>Low CAC via university guide network and shops already mapped. At modeled Y3 GMV of US$45M and 11% blended take-rate → ~US$5.0M platform revenue. LTV compounds across repeat trips, multiple crafts and guide bookings.</a:t>
             </a:r>
             <a:endParaRPr sz="900">
               <a:solidFill>
@@ -16320,7 +16530,7 @@
             <a:r>
               <a:rPr b="1" lang="en" sz="1700">
                 <a:solidFill>
-                  <a:srgbClr val="028F35"/>
+                  <a:srgbClr val="141414"/>
                 </a:solidFill>
                 <a:latin typeface="Google Sans"/>
                 <a:ea typeface="Google Sans"/>
@@ -16381,9 +16591,9 @@
               <a:buNone/>
             </a:pPr>
             <a:r>
-              <a:rPr b="1" lang="en" sz="800">
-                <a:solidFill>
-                  <a:srgbClr val="6B7573"/>
+              <a:rPr b="1" lang="en" sz="1000">
+                <a:solidFill>
+                  <a:srgbClr val="141414"/>
                 </a:solidFill>
                 <a:latin typeface="Google Sans"/>
                 <a:ea typeface="Google Sans"/>
@@ -16446,7 +16656,7 @@
             <a:r>
               <a:rPr b="1" lang="en" sz="2400">
                 <a:solidFill>
-                  <a:srgbClr val="1F2323"/>
+                  <a:srgbClr val="141414"/>
                 </a:solidFill>
                 <a:latin typeface="Google Sans"/>
                 <a:ea typeface="Google Sans"/>
@@ -16509,14 +16719,14 @@
             <a:r>
               <a:rPr b="1" lang="en" sz="1100">
                 <a:solidFill>
-                  <a:srgbClr val="028F35"/>
+                  <a:srgbClr val="141414"/>
                 </a:solidFill>
                 <a:latin typeface="Google Sans"/>
                 <a:ea typeface="Google Sans"/>
                 <a:cs typeface="Google Sans"/>
                 <a:sym typeface="Google Sans"/>
               </a:rPr>
-              <a:t>Pre-launch product build — seeking pilot partners (not live revenue yet)</a:t>
+              <a:t>What's already built — pre-launch, seeking pilot partners</a:t>
             </a:r>
             <a:endParaRPr sz="1100">
               <a:solidFill>
@@ -16575,6 +16785,11 @@
               <a:buNone/>
             </a:pPr>
             <a:r>
+              <a:rPr b="1">
+                <a:solidFill>
+                  <a:srgbClr val="141414"/>
+                </a:solidFill>
+              </a:rPr>
               <a:t/>
             </a:r>
             <a:endParaRPr/>
@@ -16623,7 +16838,7 @@
             <a:r>
               <a:rPr b="1" lang="en" sz="1800">
                 <a:solidFill>
-                  <a:srgbClr val="028F35"/>
+                  <a:srgbClr val="141414"/>
                 </a:solidFill>
                 <a:latin typeface="Nunito"/>
                 <a:ea typeface="Nunito"/>
@@ -16684,16 +16899,16 @@
               <a:buNone/>
             </a:pPr>
             <a:r>
-              <a:rPr lang="en" sz="900">
-                <a:solidFill>
-                  <a:srgbClr val="1F2323"/>
+              <a:rPr lang="en" sz="900" b="1">
+                <a:solidFill>
+                  <a:srgbClr val="141414"/>
                 </a:solidFill>
                 <a:latin typeface="Nunito"/>
                 <a:ea typeface="Nunito"/>
                 <a:cs typeface="Nunito"/>
                 <a:sym typeface="Nunito"/>
               </a:rPr>
-              <a:t>Curated crafts listed</a:t>
+              <a:t>Curated crafts listed across 24+ named Kenyan shops (KES 2,200–15,200)</a:t>
             </a:r>
             <a:endParaRPr sz="900">
               <a:solidFill>
@@ -16752,6 +16967,11 @@
               <a:buNone/>
             </a:pPr>
             <a:r>
+              <a:rPr b="1">
+                <a:solidFill>
+                  <a:srgbClr val="141414"/>
+                </a:solidFill>
+              </a:rPr>
               <a:t/>
             </a:r>
             <a:endParaRPr/>
@@ -16800,14 +17020,14 @@
             <a:r>
               <a:rPr b="1" lang="en" sz="1800">
                 <a:solidFill>
-                  <a:srgbClr val="028F35"/>
+                  <a:srgbClr val="141414"/>
                 </a:solidFill>
                 <a:latin typeface="Nunito"/>
                 <a:ea typeface="Nunito"/>
                 <a:cs typeface="Nunito"/>
                 <a:sym typeface="Nunito"/>
               </a:rPr>
-              <a:t>24+</a:t>
+              <a:t>15</a:t>
             </a:r>
             <a:endParaRPr sz="1800">
               <a:solidFill>
@@ -16861,16 +17081,16 @@
               <a:buNone/>
             </a:pPr>
             <a:r>
-              <a:rPr lang="en" sz="900">
-                <a:solidFill>
-                  <a:srgbClr val="1F2323"/>
+              <a:rPr lang="en" sz="900" b="1">
+                <a:solidFill>
+                  <a:srgbClr val="141414"/>
                 </a:solidFill>
                 <a:latin typeface="Nunito"/>
                 <a:ea typeface="Nunito"/>
                 <a:cs typeface="Nunito"/>
                 <a:sym typeface="Nunito"/>
               </a:rPr>
-              <a:t>Named Kenyan shops mapped</a:t>
+              <a:t>Parks &amp; destinations mapped — 10 in Kenya + 5 across Africa</a:t>
             </a:r>
             <a:endParaRPr sz="900">
               <a:solidFill>
@@ -16929,6 +17149,11 @@
               <a:buNone/>
             </a:pPr>
             <a:r>
+              <a:rPr b="1">
+                <a:solidFill>
+                  <a:srgbClr val="141414"/>
+                </a:solidFill>
+              </a:rPr>
               <a:t/>
             </a:r>
             <a:endParaRPr/>
@@ -16977,14 +17202,14 @@
             <a:r>
               <a:rPr b="1" lang="en" sz="1800">
                 <a:solidFill>
-                  <a:srgbClr val="028F35"/>
+                  <a:srgbClr val="141414"/>
                 </a:solidFill>
                 <a:latin typeface="Nunito"/>
                 <a:ea typeface="Nunito"/>
                 <a:cs typeface="Nunito"/>
                 <a:sym typeface="Nunito"/>
               </a:rPr>
-              <a:t>Pre-rev</a:t>
+              <a:t>12</a:t>
             </a:r>
             <a:endParaRPr sz="1800">
               <a:solidFill>
@@ -17038,16 +17263,16 @@
               <a:buNone/>
             </a:pPr>
             <a:r>
-              <a:rPr lang="en" sz="900">
-                <a:solidFill>
-                  <a:srgbClr val="1F2323"/>
+              <a:rPr lang="en" sz="900" b="1">
+                <a:solidFill>
+                  <a:srgbClr val="141414"/>
                 </a:solidFill>
                 <a:latin typeface="Nunito"/>
                 <a:ea typeface="Nunito"/>
                 <a:cs typeface="Nunito"/>
                 <a:sym typeface="Nunito"/>
               </a:rPr>
-              <a:t>Seeking pilot capital</a:t>
+              <a:t>Vetted student guides from 12 Kenyan universities</a:t>
             </a:r>
             <a:endParaRPr sz="900">
               <a:solidFill>
@@ -17106,6 +17331,11 @@
               <a:buNone/>
             </a:pPr>
             <a:r>
+              <a:rPr b="1">
+                <a:solidFill>
+                  <a:srgbClr val="141414"/>
+                </a:solidFill>
+              </a:rPr>
               <a:t/>
             </a:r>
             <a:endParaRPr/>
@@ -17154,7 +17384,7 @@
             <a:r>
               <a:rPr b="1" lang="en" sz="1800">
                 <a:solidFill>
-                  <a:srgbClr val="028F35"/>
+                  <a:srgbClr val="141414"/>
                 </a:solidFill>
                 <a:latin typeface="Nunito"/>
                 <a:ea typeface="Nunito"/>
@@ -17215,16 +17445,16 @@
               <a:buNone/>
             </a:pPr>
             <a:r>
-              <a:rPr lang="en" sz="900">
-                <a:solidFill>
-                  <a:srgbClr val="1F2323"/>
+              <a:rPr lang="en" sz="900" b="1">
+                <a:solidFill>
+                  <a:srgbClr val="141414"/>
                 </a:solidFill>
                 <a:latin typeface="Nunito"/>
                 <a:ea typeface="Nunito"/>
                 <a:cs typeface="Nunito"/>
                 <a:sym typeface="Nunito"/>
               </a:rPr>
-              <a:t>Live M-Pesa STK Push</a:t>
+              <a:t>Working M-Pesa STK Push — live gateway, phone validation &amp; status polling</a:t>
             </a:r>
             <a:endParaRPr sz="900">
               <a:solidFill>
@@ -17359,7 +17589,7 @@
             <a:r>
               <a:rPr b="1" lang="en" sz="1700">
                 <a:solidFill>
-                  <a:srgbClr val="028F35"/>
+                  <a:srgbClr val="141414"/>
                 </a:solidFill>
                 <a:latin typeface="Google Sans"/>
                 <a:ea typeface="Google Sans"/>
@@ -17420,9 +17650,9 @@
               <a:buNone/>
             </a:pPr>
             <a:r>
-              <a:rPr b="1" lang="en" sz="800">
-                <a:solidFill>
-                  <a:srgbClr val="6B7573"/>
+              <a:rPr b="1" lang="en" sz="1000">
+                <a:solidFill>
+                  <a:srgbClr val="141414"/>
                 </a:solidFill>
                 <a:latin typeface="Google Sans"/>
                 <a:ea typeface="Google Sans"/>
@@ -17485,7 +17715,7 @@
             <a:r>
               <a:rPr b="1" lang="en" sz="2400">
                 <a:solidFill>
-                  <a:srgbClr val="1F2323"/>
+                  <a:srgbClr val="141414"/>
                 </a:solidFill>
                 <a:latin typeface="Google Sans"/>
                 <a:ea typeface="Google Sans"/>
@@ -17548,7 +17778,7 @@
             <a:r>
               <a:rPr b="1" lang="en" sz="1100">
                 <a:solidFill>
-                  <a:srgbClr val="028F35"/>
+                  <a:srgbClr val="141414"/>
                 </a:solidFill>
                 <a:latin typeface="Google Sans"/>
                 <a:ea typeface="Google Sans"/>
@@ -17661,9 +17891,9 @@
               <a:buNone/>
             </a:pPr>
             <a:r>
-              <a:rPr i="1" lang="en" sz="800">
-                <a:solidFill>
-                  <a:srgbClr val="6B7573"/>
+              <a:rPr i="1" lang="en" sz="1000" b="1">
+                <a:solidFill>
+                  <a:srgbClr val="141414"/>
                 </a:solidFill>
                 <a:latin typeface="Nunito"/>
                 <a:ea typeface="Nunito"/>
@@ -17724,9 +17954,9 @@
               <a:buNone/>
             </a:pPr>
             <a:r>
-              <a:rPr i="1" lang="en" sz="800">
-                <a:solidFill>
-                  <a:srgbClr val="6B7573"/>
+              <a:rPr i="1" lang="en" sz="1000" b="1">
+                <a:solidFill>
+                  <a:srgbClr val="141414"/>
                 </a:solidFill>
                 <a:latin typeface="Arial"/>
                 <a:ea typeface="Arial"/>
@@ -17792,6 +18022,11 @@
               <a:buNone/>
             </a:pPr>
             <a:r>
+              <a:rPr b="1">
+                <a:solidFill>
+                  <a:srgbClr val="141414"/>
+                </a:solidFill>
+              </a:rPr>
               <a:t/>
             </a:r>
             <a:endParaRPr/>
@@ -17838,9 +18073,9 @@
               <a:buNone/>
             </a:pPr>
             <a:r>
-              <a:rPr b="1" lang="en" sz="800">
-                <a:solidFill>
-                  <a:srgbClr val="FFFFFF"/>
+              <a:rPr b="1" lang="en" sz="1000">
+                <a:solidFill>
+                  <a:srgbClr val="141414"/>
                 </a:solidFill>
                 <a:latin typeface="Nunito"/>
                 <a:ea typeface="Nunito"/>
@@ -17906,6 +18141,11 @@
               <a:buNone/>
             </a:pPr>
             <a:r>
+              <a:rPr b="1">
+                <a:solidFill>
+                  <a:srgbClr val="141414"/>
+                </a:solidFill>
+              </a:rPr>
               <a:t/>
             </a:r>
             <a:endParaRPr>
@@ -17957,9 +18197,9 @@
               <a:buNone/>
             </a:pPr>
             <a:r>
-              <a:rPr lang="en" sz="700">
-                <a:solidFill>
-                  <a:srgbClr val="6B7573"/>
+              <a:rPr lang="en" sz="1000" b="1">
+                <a:solidFill>
+                  <a:srgbClr val="141414"/>
                 </a:solidFill>
                 <a:latin typeface="Nunito"/>
                 <a:ea typeface="Nunito"/>
@@ -18025,6 +18265,11 @@
               <a:buNone/>
             </a:pPr>
             <a:r>
+              <a:rPr b="1">
+                <a:solidFill>
+                  <a:srgbClr val="141414"/>
+                </a:solidFill>
+              </a:rPr>
               <a:t/>
             </a:r>
             <a:endParaRPr>
@@ -18076,9 +18321,9 @@
               <a:buNone/>
             </a:pPr>
             <a:r>
-              <a:rPr lang="en" sz="700">
-                <a:solidFill>
-                  <a:srgbClr val="6B7573"/>
+              <a:rPr lang="en" sz="1000" b="1">
+                <a:solidFill>
+                  <a:srgbClr val="141414"/>
                 </a:solidFill>
                 <a:latin typeface="Nunito"/>
                 <a:ea typeface="Nunito"/>
@@ -18144,6 +18389,11 @@
               <a:buNone/>
             </a:pPr>
             <a:r>
+              <a:rPr b="1">
+                <a:solidFill>
+                  <a:srgbClr val="141414"/>
+                </a:solidFill>
+              </a:rPr>
               <a:t/>
             </a:r>
             <a:endParaRPr>
@@ -18195,9 +18445,9 @@
               <a:buNone/>
             </a:pPr>
             <a:r>
-              <a:rPr lang="en" sz="700">
-                <a:solidFill>
-                  <a:srgbClr val="6B7573"/>
+              <a:rPr lang="en" sz="1000" b="1">
+                <a:solidFill>
+                  <a:srgbClr val="141414"/>
                 </a:solidFill>
                 <a:latin typeface="Nunito"/>
                 <a:ea typeface="Nunito"/>
@@ -18263,6 +18513,11 @@
               <a:buNone/>
             </a:pPr>
             <a:r>
+              <a:rPr b="1">
+                <a:solidFill>
+                  <a:srgbClr val="141414"/>
+                </a:solidFill>
+              </a:rPr>
               <a:t/>
             </a:r>
             <a:endParaRPr/>
@@ -18312,16 +18567,16 @@
               <a:buNone/>
             </a:pPr>
             <a:r>
-              <a:rPr i="1" lang="en" sz="900">
-                <a:solidFill>
-                  <a:srgbClr val="6B7573"/>
+              <a:rPr i="1" lang="en" sz="900" b="1">
+                <a:solidFill>
+                  <a:srgbClr val="141414"/>
                 </a:solidFill>
                 <a:latin typeface="Arial"/>
                 <a:ea typeface="Arial"/>
                 <a:cs typeface="Arial"/>
                 <a:sym typeface="Arial"/>
               </a:rPr>
-              <a:t>• Global OTAs charge 20–30% and are card-first; they don’t sell named Kenyan artisan shops or student guides.</a:t>
+              <a:t>• Global OTAs charge 20–30% commission and don't touch M-Pesa or named artisan shops. Aurora does both, natively — where mobile money reaches ~98% of mobile subscriptions.</a:t>
             </a:r>
             <a:endParaRPr sz="900">
               <a:solidFill>
@@ -18352,7 +18607,12 @@
               <a:buNone/>
             </a:pPr>
             <a:r>
-              <a:t>• SafariBookings lists tours but does not process payment or sell crafts/guides directly.</a:t>
+              <a:rPr b="1">
+                <a:solidFill>
+                  <a:srgbClr val="141414"/>
+                </a:solidFill>
+              </a:rPr>
+              <a:t>• SafariBookings aggregates operator tours but does not process payment or sell crafts/guides directly. Viator, GetYourGuide and Klook are card-first and generic.</a:t>
             </a:r>
             <a:endParaRPr sz="900">
               <a:solidFill>
@@ -18383,16 +18643,16 @@
               <a:buNone/>
             </a:pPr>
             <a:r>
-              <a:rPr i="1" lang="en" sz="900">
-                <a:solidFill>
-                  <a:srgbClr val="6B7573"/>
+              <a:rPr i="1" lang="en" sz="900" b="1">
+                <a:solidFill>
+                  <a:srgbClr val="141414"/>
                 </a:solidFill>
                 <a:latin typeface="Arial"/>
                 <a:ea typeface="Arial"/>
                 <a:cs typeface="Arial"/>
                 <a:sym typeface="Arial"/>
               </a:rPr>
-              <a:t>• Defensible advantage: M-Pesa-native checkout + verified local shops/guides in one Kenya-first journey (~98% mobile-money reach).</a:t>
+              <a:t>• Defensible advantage: M-Pesa-native checkout + verified local shops/guides in one Kenya-first journey.</a:t>
             </a:r>
             <a:endParaRPr sz="900">
               <a:solidFill>
@@ -18423,6 +18683,11 @@
               <a:buNone/>
             </a:pPr>
             <a:r>
+              <a:rPr b="1">
+                <a:solidFill>
+                  <a:srgbClr val="141414"/>
+                </a:solidFill>
+              </a:rPr>
               <a:t/>
             </a:r>
             <a:endParaRPr sz="900">
@@ -18454,9 +18719,9 @@
               <a:buNone/>
             </a:pPr>
             <a:r>
-              <a:rPr i="1" lang="en" sz="900">
-                <a:solidFill>
-                  <a:srgbClr val="6B7573"/>
+              <a:rPr i="1" lang="en" sz="900" b="1">
+                <a:solidFill>
+                  <a:srgbClr val="141414"/>
                 </a:solidFill>
                 <a:latin typeface="Arial"/>
                 <a:ea typeface="Arial"/>
@@ -18625,7 +18890,7 @@
             <a:r>
               <a:rPr b="1" lang="en" sz="1700">
                 <a:solidFill>
-                  <a:srgbClr val="028F35"/>
+                  <a:srgbClr val="141414"/>
                 </a:solidFill>
                 <a:latin typeface="Google Sans"/>
                 <a:ea typeface="Google Sans"/>
@@ -18686,9 +18951,9 @@
               <a:buNone/>
             </a:pPr>
             <a:r>
-              <a:rPr b="1" lang="en" sz="800">
-                <a:solidFill>
-                  <a:srgbClr val="6B7573"/>
+              <a:rPr b="1" lang="en" sz="1000">
+                <a:solidFill>
+                  <a:srgbClr val="141414"/>
                 </a:solidFill>
                 <a:latin typeface="Google Sans"/>
                 <a:ea typeface="Google Sans"/>
@@ -18751,7 +19016,7 @@
             <a:r>
               <a:rPr b="1" lang="en" sz="2400">
                 <a:solidFill>
-                  <a:srgbClr val="1F2323"/>
+                  <a:srgbClr val="141414"/>
                 </a:solidFill>
                 <a:latin typeface="Google Sans"/>
                 <a:ea typeface="Google Sans"/>
@@ -18814,14 +19079,14 @@
             <a:r>
               <a:rPr b="1" lang="en" sz="1100">
                 <a:solidFill>
-                  <a:srgbClr val="028F35"/>
+                  <a:srgbClr val="141414"/>
                 </a:solidFill>
                 <a:latin typeface="Google Sans"/>
                 <a:ea typeface="Google Sans"/>
                 <a:cs typeface="Google Sans"/>
                 <a:sym typeface="Google Sans"/>
               </a:rPr>
-              <a:t>How you'll acquire and scale users</a:t>
+              <a:t>How Aurora Travels acquires and scales users</a:t>
             </a:r>
             <a:endParaRPr sz="1100">
               <a:solidFill>
@@ -18874,6 +19139,11 @@
               <a:buNone/>
             </a:pPr>
             <a:r>
+              <a:rPr b="1">
+                <a:solidFill>
+                  <a:srgbClr val="141414"/>
+                </a:solidFill>
+              </a:rPr>
               <a:t/>
             </a:r>
             <a:endParaRPr/>
@@ -18922,7 +19192,7 @@
             <a:r>
               <a:rPr b="1" lang="en" sz="1000">
                 <a:solidFill>
-                  <a:srgbClr val="FFFFFF"/>
+                  <a:srgbClr val="141414"/>
                 </a:solidFill>
                 <a:latin typeface="Nunito"/>
                 <a:ea typeface="Nunito"/>
@@ -18988,6 +19258,11 @@
               <a:buNone/>
             </a:pPr>
             <a:r>
+              <a:rPr b="1">
+                <a:solidFill>
+                  <a:srgbClr val="141414"/>
+                </a:solidFill>
+              </a:rPr>
               <a:t/>
             </a:r>
             <a:endParaRPr/>
@@ -19037,16 +19312,16 @@
               <a:buNone/>
             </a:pPr>
             <a:r>
-              <a:rPr i="1" lang="en" sz="900">
-                <a:solidFill>
-                  <a:srgbClr val="6B7573"/>
+              <a:rPr i="1" lang="en" sz="900" b="1">
+                <a:solidFill>
+                  <a:srgbClr val="141414"/>
                 </a:solidFill>
                 <a:latin typeface="Nunito"/>
                 <a:ea typeface="Nunito"/>
                 <a:cs typeface="Nunito"/>
                 <a:sym typeface="Nunito"/>
               </a:rPr>
-              <a:t>Nairobi + Maasai Mara gateway (Narok). Onboard mapped shops — Maasai Market, Tabaka Soapstone, Wamunyu Carvers, Kazuri — and first university guide cohort. Target: 40 shops, 40 guides, first 5,000 paid transactions.</a:t>
+              <a:t>Nairobi and the Maasai Mara gateway (Narok). Onboard shop partners already mapped — Maasai Market Nairobi, Tabaka Soapstone (Kisii), Wamunyu Carvers (Machakos), Kazuri Beads — and the first guide cohort from partner universities. Target: 40 shops, 40 guides, first 5,000 paid transactions.</a:t>
             </a:r>
             <a:endParaRPr sz="900">
               <a:solidFill>
@@ -19099,6 +19374,11 @@
               <a:buNone/>
             </a:pPr>
             <a:r>
+              <a:rPr b="1">
+                <a:solidFill>
+                  <a:srgbClr val="141414"/>
+                </a:solidFill>
+              </a:rPr>
               <a:t/>
             </a:r>
             <a:endParaRPr/>
@@ -19147,7 +19427,7 @@
             <a:r>
               <a:rPr b="1" lang="en" sz="1000">
                 <a:solidFill>
-                  <a:srgbClr val="FFFFFF"/>
+                  <a:srgbClr val="141414"/>
                 </a:solidFill>
                 <a:latin typeface="Nunito"/>
                 <a:ea typeface="Nunito"/>
@@ -19213,6 +19493,11 @@
               <a:buNone/>
             </a:pPr>
             <a:r>
+              <a:rPr b="1">
+                <a:solidFill>
+                  <a:srgbClr val="141414"/>
+                </a:solidFill>
+              </a:rPr>
               <a:t/>
             </a:r>
             <a:endParaRPr/>
@@ -19262,16 +19547,16 @@
               <a:buNone/>
             </a:pPr>
             <a:r>
-              <a:rPr i="1" lang="en" sz="900">
-                <a:solidFill>
-                  <a:srgbClr val="6B7573"/>
+              <a:rPr i="1" lang="en" sz="900" b="1">
+                <a:solidFill>
+                  <a:srgbClr val="141414"/>
                 </a:solidFill>
                 <a:latin typeface="Nunito"/>
                 <a:ea typeface="Nunito"/>
                 <a:cs typeface="Nunito"/>
                 <a:sym typeface="Nunito"/>
               </a:rPr>
-              <a:t>Extend across more of Kenya’s 47 counties toward 2027 targets (5.5M international arrivals; KES 1T earnings). Prioritise 2025 top source markets: US, Uganda, Tanzania, UK.</a:t>
+              <a:t>Extend across more of Kenya's 47 counties toward the government's 2027 ambition of 5.5M international arrivals and KES 1T tourism earnings. Prioritise 2025 top source markets: United States, Uganda, Tanzania and the United Kingdom (Ministry report).</a:t>
             </a:r>
             <a:endParaRPr sz="900">
               <a:solidFill>
@@ -19324,6 +19609,11 @@
               <a:buNone/>
             </a:pPr>
             <a:r>
+              <a:rPr b="1">
+                <a:solidFill>
+                  <a:srgbClr val="141414"/>
+                </a:solidFill>
+              </a:rPr>
               <a:t/>
             </a:r>
             <a:endParaRPr/>
@@ -19372,7 +19662,7 @@
             <a:r>
               <a:rPr b="1" lang="en" sz="1000">
                 <a:solidFill>
-                  <a:srgbClr val="FFFFFF"/>
+                  <a:srgbClr val="141414"/>
                 </a:solidFill>
                 <a:latin typeface="Nunito"/>
                 <a:ea typeface="Nunito"/>
@@ -19438,6 +19728,11 @@
               <a:buNone/>
             </a:pPr>
             <a:r>
+              <a:rPr b="1">
+                <a:solidFill>
+                  <a:srgbClr val="141414"/>
+                </a:solidFill>
+              </a:rPr>
               <a:t/>
             </a:r>
             <a:endParaRPr/>
@@ -19487,16 +19782,16 @@
               <a:buNone/>
             </a:pPr>
             <a:r>
-              <a:rPr i="1" lang="en" sz="900">
-                <a:solidFill>
-                  <a:srgbClr val="6B7573"/>
+              <a:rPr i="1" lang="en" sz="900" b="1">
+                <a:solidFill>
+                  <a:srgbClr val="141414"/>
                 </a:solidFill>
                 <a:latin typeface="Nunito"/>
                 <a:ea typeface="Nunito"/>
                 <a:cs typeface="Nunito"/>
                 <a:sym typeface="Nunito"/>
               </a:rPr>
-              <a:t>Expand into the East African safari circuit (Tanzania, Uganda) already on Aurora’s park map — Mara–Serengeti / Great Rift corridor — with cross-border craft and guide networks.</a:t>
+              <a:t>Expand into the shared East African safari circuit (Tanzania, Uganda) that Aurora's park map already spans — the Great Rift / Mara–Serengeti ecosystem — with cross-border M-Pesa and craft corridors.</a:t>
             </a:r>
             <a:endParaRPr sz="900">
               <a:solidFill>

</xml_diff>